<commit_message>
updated playwright and samples
</commit_message>
<xml_diff>
--- a/sample-files/sample.pptx
+++ b/sample-files/sample.pptx
@@ -293,7 +293,7 @@
       </p:grpSpPr>
       <p:sp>
         <p:nvSpPr>
-          <p:cNvPr id="620583952" name="Shape 134"/>
+          <p:cNvPr id="1599814977" name="Shape 134"/>
           <p:cNvSpPr/>
           <p:nvPr>
             <p:ph type="sldImg"/>
@@ -321,7 +321,7 @@
       </p:sp>
       <p:sp>
         <p:nvSpPr>
-          <p:cNvPr id="490607779" name="Shape 135"/>
+          <p:cNvPr id="1961840337" name="Shape 135"/>
           <p:cNvSpPr/>
           <p:nvPr>
             <p:ph type="body" sz="quarter" idx="1"/>
@@ -464,7 +464,7 @@
       </p:grpSpPr>
       <p:sp>
         <p:nvSpPr>
-          <p:cNvPr id="2" name="Slide Image Placeholder 1"/>
+          <p:cNvPr id="1881737617" name="Slide Image Placeholder 1"/>
           <p:cNvSpPr>
             <a:spLocks noChangeAspect="1" noGrp="1" noRot="1"/>
           </p:cNvSpPr>
@@ -476,7 +476,7 @@
       </p:sp>
       <p:sp>
         <p:nvSpPr>
-          <p:cNvPr id="3" name="Notes Placeholder 2"/>
+          <p:cNvPr id="1992959472" name="Notes Placeholder 2"/>
           <p:cNvSpPr>
             <a:spLocks noGrp="1"/>
           </p:cNvSpPr>
@@ -498,7 +498,7 @@
       </p:sp>
       <p:sp>
         <p:nvSpPr>
-          <p:cNvPr id="4" name="Slide Number Placeholder 3"/>
+          <p:cNvPr id="1736322264" name="Slide Number Placeholder 3"/>
           <p:cNvSpPr>
             <a:spLocks noGrp="1"/>
           </p:cNvSpPr>
@@ -549,7 +549,7 @@
       </p:grpSpPr>
       <p:sp>
         <p:nvSpPr>
-          <p:cNvPr id="958986120" name="Title Text"/>
+          <p:cNvPr id="1232131813" name="Title Text"/>
           <p:cNvSpPr txBox="1"/>
           <p:nvPr>
             <p:ph type="title"/>
@@ -581,7 +581,7 @@
       </p:sp>
       <p:sp>
         <p:nvSpPr>
-          <p:cNvPr id="1718990709" name="Body Level One…"/>
+          <p:cNvPr id="2060001999" name="Body Level One…"/>
           <p:cNvSpPr txBox="1"/>
           <p:nvPr>
             <p:ph type="body" sz="quarter" idx="1"/>
@@ -704,7 +704,7 @@
       </p:sp>
       <p:sp>
         <p:nvSpPr>
-          <p:cNvPr id="1814026573" name="Slide Number"/>
+          <p:cNvPr id="1512158261" name="Slide Number"/>
           <p:cNvSpPr txBox="1"/>
           <p:nvPr>
             <p:ph type="sldNum" sz="quarter" idx="2"/>
@@ -757,7 +757,7 @@
       </p:grpSpPr>
       <p:sp>
         <p:nvSpPr>
-          <p:cNvPr id="215716306" name="Body Level One…"/>
+          <p:cNvPr id="1543843057" name="Body Level One…"/>
           <p:cNvSpPr txBox="1"/>
           <p:nvPr>
             <p:ph type="body" idx="1"/>
@@ -850,7 +850,7 @@
       </p:sp>
       <p:sp>
         <p:nvSpPr>
-          <p:cNvPr id="211545165" name="Slide Number"/>
+          <p:cNvPr id="710671666" name="Slide Number"/>
           <p:cNvSpPr txBox="1"/>
           <p:nvPr>
             <p:ph type="sldNum" sz="quarter" idx="2"/>
@@ -903,7 +903,7 @@
       </p:grpSpPr>
       <p:sp>
         <p:nvSpPr>
-          <p:cNvPr id="1469861949" name="Close-up of an orange flower surrounded by large tropical leaves"/>
+          <p:cNvPr id="842562090" name="Close-up of an orange flower surrounded by large tropical leaves"/>
           <p:cNvSpPr/>
           <p:nvPr>
             <p:ph type="pic" sz="quarter" idx="21"/>
@@ -933,7 +933,7 @@
       </p:sp>
       <p:sp>
         <p:nvSpPr>
-          <p:cNvPr id="1640187885" name="Close-up of a red-eyed tree frog perched on a leaf"/>
+          <p:cNvPr id="1504735642" name="Close-up of a red-eyed tree frog perched on a leaf"/>
           <p:cNvSpPr/>
           <p:nvPr>
             <p:ph type="pic" sz="quarter" idx="22"/>
@@ -963,7 +963,7 @@
       </p:sp>
       <p:sp>
         <p:nvSpPr>
-          <p:cNvPr id="951690275" name="River flowing through a tropical forest"/>
+          <p:cNvPr id="884666299" name="River flowing through a tropical forest"/>
           <p:cNvSpPr/>
           <p:nvPr>
             <p:ph type="pic" idx="23"/>
@@ -993,7 +993,7 @@
       </p:sp>
       <p:sp>
         <p:nvSpPr>
-          <p:cNvPr id="1112717383" name="Slide Number"/>
+          <p:cNvPr id="440783149" name="Slide Number"/>
           <p:cNvSpPr txBox="1"/>
           <p:nvPr>
             <p:ph type="sldNum" sz="quarter" idx="2"/>
@@ -1046,7 +1046,7 @@
       </p:grpSpPr>
       <p:sp>
         <p:nvSpPr>
-          <p:cNvPr id="313718528" name="–Johnny Appleseed"/>
+          <p:cNvPr id="910370104" name="–Johnny Appleseed"/>
           <p:cNvSpPr txBox="1"/>
           <p:nvPr>
             <p:ph type="body" sz="quarter" idx="21"/>
@@ -1091,7 +1091,7 @@
       </p:sp>
       <p:sp>
         <p:nvSpPr>
-          <p:cNvPr id="218511664" name="“Type a quote here.”"/>
+          <p:cNvPr id="1133822696" name="“Type a quote here.”"/>
           <p:cNvSpPr txBox="1"/>
           <p:nvPr>
             <p:ph type="body" sz="quarter" idx="22"/>
@@ -1140,7 +1140,7 @@
       </p:sp>
       <p:sp>
         <p:nvSpPr>
-          <p:cNvPr id="1230146830" name="Slide Number"/>
+          <p:cNvPr id="613970757" name="Slide Number"/>
           <p:cNvSpPr txBox="1"/>
           <p:nvPr>
             <p:ph type="sldNum" sz="quarter" idx="2"/>
@@ -1193,7 +1193,7 @@
       </p:grpSpPr>
       <p:sp>
         <p:nvSpPr>
-          <p:cNvPr id="1251693123" name="river flowing through a tropical forest"/>
+          <p:cNvPr id="1053540655" name="river flowing through a tropical forest"/>
           <p:cNvSpPr/>
           <p:nvPr>
             <p:ph type="pic" idx="21"/>
@@ -1223,7 +1223,7 @@
       </p:sp>
       <p:sp>
         <p:nvSpPr>
-          <p:cNvPr id="1349654308" name="Slide Number"/>
+          <p:cNvPr id="343010927" name="Slide Number"/>
           <p:cNvSpPr txBox="1"/>
           <p:nvPr>
             <p:ph type="sldNum" sz="quarter" idx="2"/>
@@ -1276,7 +1276,7 @@
       </p:grpSpPr>
       <p:sp>
         <p:nvSpPr>
-          <p:cNvPr id="1447115745" name="Slide Number"/>
+          <p:cNvPr id="1258523005" name="Slide Number"/>
           <p:cNvSpPr txBox="1"/>
           <p:nvPr>
             <p:ph type="sldNum" sz="quarter" idx="2"/>
@@ -1329,7 +1329,7 @@
       </p:grpSpPr>
       <p:sp>
         <p:nvSpPr>
-          <p:cNvPr id="1747468626" name="River flowing through a tropical forest"/>
+          <p:cNvPr id="394409174" name="River flowing through a tropical forest"/>
           <p:cNvSpPr/>
           <p:nvPr>
             <p:ph type="pic" idx="21"/>
@@ -1359,7 +1359,7 @@
       </p:sp>
       <p:sp>
         <p:nvSpPr>
-          <p:cNvPr id="821183091" name="Title Text"/>
+          <p:cNvPr id="4533537" name="Title Text"/>
           <p:cNvSpPr txBox="1"/>
           <p:nvPr>
             <p:ph type="title"/>
@@ -1391,7 +1391,7 @@
       </p:sp>
       <p:sp>
         <p:nvSpPr>
-          <p:cNvPr id="508744095" name="Body Level One…"/>
+          <p:cNvPr id="1801175522" name="Body Level One…"/>
           <p:cNvSpPr txBox="1"/>
           <p:nvPr>
             <p:ph type="body" sz="quarter" idx="1"/>
@@ -1514,7 +1514,7 @@
       </p:sp>
       <p:sp>
         <p:nvSpPr>
-          <p:cNvPr id="1528677633" name="Slide Number"/>
+          <p:cNvPr id="28460533" name="Slide Number"/>
           <p:cNvSpPr txBox="1"/>
           <p:nvPr>
             <p:ph type="sldNum" sz="quarter" idx="2"/>
@@ -1567,7 +1567,7 @@
       </p:grpSpPr>
       <p:sp>
         <p:nvSpPr>
-          <p:cNvPr id="1452750617" name="Title Text"/>
+          <p:cNvPr id="2137916603" name="Title Text"/>
           <p:cNvSpPr txBox="1"/>
           <p:nvPr>
             <p:ph type="title"/>
@@ -1599,7 +1599,7 @@
       </p:sp>
       <p:sp>
         <p:nvSpPr>
-          <p:cNvPr id="1753058353" name="Slide Number"/>
+          <p:cNvPr id="2059238008" name="Slide Number"/>
           <p:cNvSpPr txBox="1"/>
           <p:nvPr>
             <p:ph type="sldNum" sz="quarter" idx="2"/>
@@ -1652,7 +1652,7 @@
       </p:grpSpPr>
       <p:sp>
         <p:nvSpPr>
-          <p:cNvPr id="1415054560" name="Close-up of an orange flower surrounded by large tropical leaves"/>
+          <p:cNvPr id="1653995056" name="Close-up of an orange flower surrounded by large tropical leaves"/>
           <p:cNvSpPr/>
           <p:nvPr>
             <p:ph type="pic" idx="21"/>
@@ -1682,7 +1682,7 @@
       </p:sp>
       <p:sp>
         <p:nvSpPr>
-          <p:cNvPr id="1733009731" name="Title Text"/>
+          <p:cNvPr id="1053904246" name="Title Text"/>
           <p:cNvSpPr txBox="1"/>
           <p:nvPr>
             <p:ph type="title"/>
@@ -1718,7 +1718,7 @@
       </p:sp>
       <p:sp>
         <p:nvSpPr>
-          <p:cNvPr id="1386951147" name="Body Level One…"/>
+          <p:cNvPr id="84072699" name="Body Level One…"/>
           <p:cNvSpPr txBox="1"/>
           <p:nvPr>
             <p:ph type="body" sz="quarter" idx="1"/>
@@ -1841,7 +1841,7 @@
       </p:sp>
       <p:sp>
         <p:nvSpPr>
-          <p:cNvPr id="1415861216" name="Slide Number"/>
+          <p:cNvPr id="262215894" name="Slide Number"/>
           <p:cNvSpPr txBox="1"/>
           <p:nvPr>
             <p:ph type="sldNum" sz="quarter" idx="2"/>
@@ -1894,7 +1894,7 @@
       </p:grpSpPr>
       <p:sp>
         <p:nvSpPr>
-          <p:cNvPr id="923551078" name="Title Text"/>
+          <p:cNvPr id="369018583" name="Title Text"/>
           <p:cNvSpPr txBox="1"/>
           <p:nvPr>
             <p:ph type="title"/>
@@ -1922,7 +1922,7 @@
       </p:sp>
       <p:sp>
         <p:nvSpPr>
-          <p:cNvPr id="1816153035" name="Slide Number"/>
+          <p:cNvPr id="1229397826" name="Slide Number"/>
           <p:cNvSpPr txBox="1"/>
           <p:nvPr>
             <p:ph type="sldNum" sz="quarter" idx="2"/>
@@ -1975,7 +1975,7 @@
       </p:grpSpPr>
       <p:sp>
         <p:nvSpPr>
-          <p:cNvPr id="1648667203" name="Title Text"/>
+          <p:cNvPr id="2024912123" name="Title Text"/>
           <p:cNvSpPr txBox="1"/>
           <p:nvPr>
             <p:ph type="title"/>
@@ -2003,7 +2003,7 @@
       </p:sp>
       <p:sp>
         <p:nvSpPr>
-          <p:cNvPr id="1152746493" name="Body Level One…"/>
+          <p:cNvPr id="2067172308" name="Body Level One…"/>
           <p:cNvSpPr txBox="1"/>
           <p:nvPr>
             <p:ph type="body" idx="1"/>
@@ -2092,7 +2092,7 @@
       </p:sp>
       <p:sp>
         <p:nvSpPr>
-          <p:cNvPr id="795061034" name="Slide Number"/>
+          <p:cNvPr id="1006908168" name="Slide Number"/>
           <p:cNvSpPr txBox="1"/>
           <p:nvPr>
             <p:ph type="sldNum" sz="quarter" idx="2"/>
@@ -2145,7 +2145,7 @@
       </p:grpSpPr>
       <p:sp>
         <p:nvSpPr>
-          <p:cNvPr id="1531402662" name="Close-up of a red-eyed tree frog perched on a leaf"/>
+          <p:cNvPr id="317796159" name="Close-up of a red-eyed tree frog perched on a leaf"/>
           <p:cNvSpPr/>
           <p:nvPr>
             <p:ph type="pic" sz="half" idx="21"/>
@@ -2175,7 +2175,7 @@
       </p:sp>
       <p:sp>
         <p:nvSpPr>
-          <p:cNvPr id="91459855" name="Title Text"/>
+          <p:cNvPr id="1593834194" name="Title Text"/>
           <p:cNvSpPr txBox="1"/>
           <p:nvPr>
             <p:ph type="title"/>
@@ -2203,7 +2203,7 @@
       </p:sp>
       <p:sp>
         <p:nvSpPr>
-          <p:cNvPr id="1935781153" name="Body Level One…"/>
+          <p:cNvPr id="507921764" name="Body Level One…"/>
           <p:cNvSpPr txBox="1"/>
           <p:nvPr>
             <p:ph type="body" sz="half" idx="1"/>
@@ -2316,7 +2316,7 @@
       </p:sp>
       <p:sp>
         <p:nvSpPr>
-          <p:cNvPr id="1039098071" name="Slide Number"/>
+          <p:cNvPr id="834635244" name="Slide Number"/>
           <p:cNvSpPr txBox="1"/>
           <p:nvPr>
             <p:ph type="sldNum" sz="quarter" idx="2"/>
@@ -2369,7 +2369,7 @@
       </p:grpSpPr>
       <p:sp>
         <p:nvSpPr>
-          <p:cNvPr id="1109842687" name="Title Text"/>
+          <p:cNvPr id="164188852" name="Title Text"/>
           <p:cNvSpPr txBox="1"/>
           <p:nvPr>
             <p:ph type="title"/>
@@ -2397,7 +2397,7 @@
       </p:sp>
       <p:sp>
         <p:nvSpPr>
-          <p:cNvPr id="943152248" name="Body Level One…"/>
+          <p:cNvPr id="1517639646" name="Body Level One…"/>
           <p:cNvSpPr txBox="1"/>
           <p:nvPr>
             <p:ph type="body" sz="half" idx="1"/>
@@ -2510,7 +2510,7 @@
       </p:sp>
       <p:sp>
         <p:nvSpPr>
-          <p:cNvPr id="163739041" name="Slide Number"/>
+          <p:cNvPr id="776665343" name="Slide Number"/>
           <p:cNvSpPr txBox="1"/>
           <p:nvPr>
             <p:ph type="sldNum" sz="quarter" idx="2"/>
@@ -2563,7 +2563,7 @@
       </p:grpSpPr>
       <p:sp>
         <p:nvSpPr>
-          <p:cNvPr id="1824773800" name="Title Text"/>
+          <p:cNvPr id="1147088599" name="Title Text"/>
           <p:cNvSpPr txBox="1"/>
           <p:nvPr>
             <p:ph type="title"/>
@@ -2591,7 +2591,7 @@
       </p:sp>
       <p:sp>
         <p:nvSpPr>
-          <p:cNvPr id="1839135980" name="Body Level One…"/>
+          <p:cNvPr id="1980641827" name="Body Level One…"/>
           <p:cNvSpPr txBox="1"/>
           <p:nvPr>
             <p:ph type="body" sz="half" idx="1"/>
@@ -2704,7 +2704,7 @@
       </p:sp>
       <p:sp>
         <p:nvSpPr>
-          <p:cNvPr id="1361005062" name="Slide Number"/>
+          <p:cNvPr id="403513412" name="Slide Number"/>
           <p:cNvSpPr txBox="1"/>
           <p:nvPr>
             <p:ph type="sldNum" sz="quarter" idx="2"/>
@@ -2764,7 +2764,7 @@
       </p:grpSpPr>
       <p:sp>
         <p:nvSpPr>
-          <p:cNvPr id="130732852" name="Title Text"/>
+          <p:cNvPr id="1978627024" name="Title Text"/>
           <p:cNvSpPr txBox="1"/>
           <p:nvPr>
             <p:ph type="title"/>
@@ -2801,7 +2801,7 @@
       </p:sp>
       <p:sp>
         <p:nvSpPr>
-          <p:cNvPr id="1132041117" name="Body Level One…"/>
+          <p:cNvPr id="1387130379" name="Body Level One…"/>
           <p:cNvSpPr txBox="1"/>
           <p:nvPr>
             <p:ph type="body" idx="1"/>
@@ -2878,7 +2878,7 @@
       </p:sp>
       <p:sp>
         <p:nvSpPr>
-          <p:cNvPr id="1005232112" name="Slide Number"/>
+          <p:cNvPr id="1409529237" name="Slide Number"/>
           <p:cNvSpPr txBox="1"/>
           <p:nvPr>
             <p:ph type="sldNum" sz="quarter" idx="2"/>
@@ -3612,7 +3612,7 @@
       </p:grpSpPr>
       <p:sp>
         <p:nvSpPr>
-          <p:cNvPr id="20963923" name="My Presentation"/>
+          <p:cNvPr id="317537720" name="My Presentation"/>
           <p:cNvSpPr txBox="1"/>
           <p:nvPr>
             <p:ph type="ctrTitle"/>
@@ -3640,7 +3640,7 @@
       </p:sp>
       <p:sp>
         <p:nvSpPr>
-          <p:cNvPr id="1583487635" name="Muhammad Zeeshan"/>
+          <p:cNvPr id="2134756337" name="Muhammad Zeeshan"/>
           <p:cNvSpPr txBox="1"/>
           <p:nvPr>
             <p:ph type="subTitle" sz="quarter" idx="1"/>

</xml_diff>

<commit_message>
updated testing and linting
</commit_message>
<xml_diff>
--- a/sample-files/sample.pptx
+++ b/sample-files/sample.pptx
@@ -293,7 +293,7 @@
       </p:grpSpPr>
       <p:sp>
         <p:nvSpPr>
-          <p:cNvPr id="1599814977" name="Shape 134"/>
+          <p:cNvPr id="647219105" name="Shape 134"/>
           <p:cNvSpPr/>
           <p:nvPr>
             <p:ph type="sldImg"/>
@@ -321,7 +321,7 @@
       </p:sp>
       <p:sp>
         <p:nvSpPr>
-          <p:cNvPr id="1961840337" name="Shape 135"/>
+          <p:cNvPr id="418715547" name="Shape 135"/>
           <p:cNvSpPr/>
           <p:nvPr>
             <p:ph type="body" sz="quarter" idx="1"/>
@@ -464,7 +464,7 @@
       </p:grpSpPr>
       <p:sp>
         <p:nvSpPr>
-          <p:cNvPr id="1881737617" name="Slide Image Placeholder 1"/>
+          <p:cNvPr id="1365327404" name="Slide Image Placeholder 1"/>
           <p:cNvSpPr>
             <a:spLocks noChangeAspect="1" noGrp="1" noRot="1"/>
           </p:cNvSpPr>
@@ -476,7 +476,7 @@
       </p:sp>
       <p:sp>
         <p:nvSpPr>
-          <p:cNvPr id="1992959472" name="Notes Placeholder 2"/>
+          <p:cNvPr id="1723958378" name="Notes Placeholder 2"/>
           <p:cNvSpPr>
             <a:spLocks noGrp="1"/>
           </p:cNvSpPr>
@@ -498,7 +498,7 @@
       </p:sp>
       <p:sp>
         <p:nvSpPr>
-          <p:cNvPr id="1736322264" name="Slide Number Placeholder 3"/>
+          <p:cNvPr id="1492075266" name="Slide Number Placeholder 3"/>
           <p:cNvSpPr>
             <a:spLocks noGrp="1"/>
           </p:cNvSpPr>
@@ -549,7 +549,7 @@
       </p:grpSpPr>
       <p:sp>
         <p:nvSpPr>
-          <p:cNvPr id="1232131813" name="Title Text"/>
+          <p:cNvPr id="369862323" name="Title Text"/>
           <p:cNvSpPr txBox="1"/>
           <p:nvPr>
             <p:ph type="title"/>
@@ -581,7 +581,7 @@
       </p:sp>
       <p:sp>
         <p:nvSpPr>
-          <p:cNvPr id="2060001999" name="Body Level One…"/>
+          <p:cNvPr id="742673414" name="Body Level One…"/>
           <p:cNvSpPr txBox="1"/>
           <p:nvPr>
             <p:ph type="body" sz="quarter" idx="1"/>
@@ -704,7 +704,7 @@
       </p:sp>
       <p:sp>
         <p:nvSpPr>
-          <p:cNvPr id="1512158261" name="Slide Number"/>
+          <p:cNvPr id="520564199" name="Slide Number"/>
           <p:cNvSpPr txBox="1"/>
           <p:nvPr>
             <p:ph type="sldNum" sz="quarter" idx="2"/>
@@ -757,7 +757,7 @@
       </p:grpSpPr>
       <p:sp>
         <p:nvSpPr>
-          <p:cNvPr id="1543843057" name="Body Level One…"/>
+          <p:cNvPr id="561531567" name="Body Level One…"/>
           <p:cNvSpPr txBox="1"/>
           <p:nvPr>
             <p:ph type="body" idx="1"/>
@@ -850,7 +850,7 @@
       </p:sp>
       <p:sp>
         <p:nvSpPr>
-          <p:cNvPr id="710671666" name="Slide Number"/>
+          <p:cNvPr id="1957474363" name="Slide Number"/>
           <p:cNvSpPr txBox="1"/>
           <p:nvPr>
             <p:ph type="sldNum" sz="quarter" idx="2"/>
@@ -903,7 +903,7 @@
       </p:grpSpPr>
       <p:sp>
         <p:nvSpPr>
-          <p:cNvPr id="842562090" name="Close-up of an orange flower surrounded by large tropical leaves"/>
+          <p:cNvPr id="2089651296" name="Close-up of an orange flower surrounded by large tropical leaves"/>
           <p:cNvSpPr/>
           <p:nvPr>
             <p:ph type="pic" sz="quarter" idx="21"/>
@@ -933,7 +933,7 @@
       </p:sp>
       <p:sp>
         <p:nvSpPr>
-          <p:cNvPr id="1504735642" name="Close-up of a red-eyed tree frog perched on a leaf"/>
+          <p:cNvPr id="364056033" name="Close-up of a red-eyed tree frog perched on a leaf"/>
           <p:cNvSpPr/>
           <p:nvPr>
             <p:ph type="pic" sz="quarter" idx="22"/>
@@ -963,7 +963,7 @@
       </p:sp>
       <p:sp>
         <p:nvSpPr>
-          <p:cNvPr id="884666299" name="River flowing through a tropical forest"/>
+          <p:cNvPr id="1083470186" name="River flowing through a tropical forest"/>
           <p:cNvSpPr/>
           <p:nvPr>
             <p:ph type="pic" idx="23"/>
@@ -993,7 +993,7 @@
       </p:sp>
       <p:sp>
         <p:nvSpPr>
-          <p:cNvPr id="440783149" name="Slide Number"/>
+          <p:cNvPr id="1621314472" name="Slide Number"/>
           <p:cNvSpPr txBox="1"/>
           <p:nvPr>
             <p:ph type="sldNum" sz="quarter" idx="2"/>
@@ -1046,7 +1046,7 @@
       </p:grpSpPr>
       <p:sp>
         <p:nvSpPr>
-          <p:cNvPr id="910370104" name="–Johnny Appleseed"/>
+          <p:cNvPr id="1473737401" name="–Johnny Appleseed"/>
           <p:cNvSpPr txBox="1"/>
           <p:nvPr>
             <p:ph type="body" sz="quarter" idx="21"/>
@@ -1091,7 +1091,7 @@
       </p:sp>
       <p:sp>
         <p:nvSpPr>
-          <p:cNvPr id="1133822696" name="“Type a quote here.”"/>
+          <p:cNvPr id="222044903" name="“Type a quote here.”"/>
           <p:cNvSpPr txBox="1"/>
           <p:nvPr>
             <p:ph type="body" sz="quarter" idx="22"/>
@@ -1140,7 +1140,7 @@
       </p:sp>
       <p:sp>
         <p:nvSpPr>
-          <p:cNvPr id="613970757" name="Slide Number"/>
+          <p:cNvPr id="1377658939" name="Slide Number"/>
           <p:cNvSpPr txBox="1"/>
           <p:nvPr>
             <p:ph type="sldNum" sz="quarter" idx="2"/>
@@ -1193,7 +1193,7 @@
       </p:grpSpPr>
       <p:sp>
         <p:nvSpPr>
-          <p:cNvPr id="1053540655" name="river flowing through a tropical forest"/>
+          <p:cNvPr id="1699675117" name="river flowing through a tropical forest"/>
           <p:cNvSpPr/>
           <p:nvPr>
             <p:ph type="pic" idx="21"/>
@@ -1223,7 +1223,7 @@
       </p:sp>
       <p:sp>
         <p:nvSpPr>
-          <p:cNvPr id="343010927" name="Slide Number"/>
+          <p:cNvPr id="1232511156" name="Slide Number"/>
           <p:cNvSpPr txBox="1"/>
           <p:nvPr>
             <p:ph type="sldNum" sz="quarter" idx="2"/>
@@ -1276,7 +1276,7 @@
       </p:grpSpPr>
       <p:sp>
         <p:nvSpPr>
-          <p:cNvPr id="1258523005" name="Slide Number"/>
+          <p:cNvPr id="163275107" name="Slide Number"/>
           <p:cNvSpPr txBox="1"/>
           <p:nvPr>
             <p:ph type="sldNum" sz="quarter" idx="2"/>
@@ -1329,7 +1329,7 @@
       </p:grpSpPr>
       <p:sp>
         <p:nvSpPr>
-          <p:cNvPr id="394409174" name="River flowing through a tropical forest"/>
+          <p:cNvPr id="224788747" name="River flowing through a tropical forest"/>
           <p:cNvSpPr/>
           <p:nvPr>
             <p:ph type="pic" idx="21"/>
@@ -1359,7 +1359,7 @@
       </p:sp>
       <p:sp>
         <p:nvSpPr>
-          <p:cNvPr id="4533537" name="Title Text"/>
+          <p:cNvPr id="1771972005" name="Title Text"/>
           <p:cNvSpPr txBox="1"/>
           <p:nvPr>
             <p:ph type="title"/>
@@ -1391,7 +1391,7 @@
       </p:sp>
       <p:sp>
         <p:nvSpPr>
-          <p:cNvPr id="1801175522" name="Body Level One…"/>
+          <p:cNvPr id="1206152980" name="Body Level One…"/>
           <p:cNvSpPr txBox="1"/>
           <p:nvPr>
             <p:ph type="body" sz="quarter" idx="1"/>
@@ -1514,7 +1514,7 @@
       </p:sp>
       <p:sp>
         <p:nvSpPr>
-          <p:cNvPr id="28460533" name="Slide Number"/>
+          <p:cNvPr id="1541213785" name="Slide Number"/>
           <p:cNvSpPr txBox="1"/>
           <p:nvPr>
             <p:ph type="sldNum" sz="quarter" idx="2"/>
@@ -1567,7 +1567,7 @@
       </p:grpSpPr>
       <p:sp>
         <p:nvSpPr>
-          <p:cNvPr id="2137916603" name="Title Text"/>
+          <p:cNvPr id="2055015227" name="Title Text"/>
           <p:cNvSpPr txBox="1"/>
           <p:nvPr>
             <p:ph type="title"/>
@@ -1599,7 +1599,7 @@
       </p:sp>
       <p:sp>
         <p:nvSpPr>
-          <p:cNvPr id="2059238008" name="Slide Number"/>
+          <p:cNvPr id="1113125606" name="Slide Number"/>
           <p:cNvSpPr txBox="1"/>
           <p:nvPr>
             <p:ph type="sldNum" sz="quarter" idx="2"/>
@@ -1652,7 +1652,7 @@
       </p:grpSpPr>
       <p:sp>
         <p:nvSpPr>
-          <p:cNvPr id="1653995056" name="Close-up of an orange flower surrounded by large tropical leaves"/>
+          <p:cNvPr id="1409363241" name="Close-up of an orange flower surrounded by large tropical leaves"/>
           <p:cNvSpPr/>
           <p:nvPr>
             <p:ph type="pic" idx="21"/>
@@ -1682,7 +1682,7 @@
       </p:sp>
       <p:sp>
         <p:nvSpPr>
-          <p:cNvPr id="1053904246" name="Title Text"/>
+          <p:cNvPr id="1275223606" name="Title Text"/>
           <p:cNvSpPr txBox="1"/>
           <p:nvPr>
             <p:ph type="title"/>
@@ -1718,7 +1718,7 @@
       </p:sp>
       <p:sp>
         <p:nvSpPr>
-          <p:cNvPr id="84072699" name="Body Level One…"/>
+          <p:cNvPr id="1491217005" name="Body Level One…"/>
           <p:cNvSpPr txBox="1"/>
           <p:nvPr>
             <p:ph type="body" sz="quarter" idx="1"/>
@@ -1841,7 +1841,7 @@
       </p:sp>
       <p:sp>
         <p:nvSpPr>
-          <p:cNvPr id="262215894" name="Slide Number"/>
+          <p:cNvPr id="875878210" name="Slide Number"/>
           <p:cNvSpPr txBox="1"/>
           <p:nvPr>
             <p:ph type="sldNum" sz="quarter" idx="2"/>
@@ -1894,7 +1894,7 @@
       </p:grpSpPr>
       <p:sp>
         <p:nvSpPr>
-          <p:cNvPr id="369018583" name="Title Text"/>
+          <p:cNvPr id="1911521938" name="Title Text"/>
           <p:cNvSpPr txBox="1"/>
           <p:nvPr>
             <p:ph type="title"/>
@@ -1922,7 +1922,7 @@
       </p:sp>
       <p:sp>
         <p:nvSpPr>
-          <p:cNvPr id="1229397826" name="Slide Number"/>
+          <p:cNvPr id="370933311" name="Slide Number"/>
           <p:cNvSpPr txBox="1"/>
           <p:nvPr>
             <p:ph type="sldNum" sz="quarter" idx="2"/>
@@ -1975,7 +1975,7 @@
       </p:grpSpPr>
       <p:sp>
         <p:nvSpPr>
-          <p:cNvPr id="2024912123" name="Title Text"/>
+          <p:cNvPr id="1123396944" name="Title Text"/>
           <p:cNvSpPr txBox="1"/>
           <p:nvPr>
             <p:ph type="title"/>
@@ -2003,7 +2003,7 @@
       </p:sp>
       <p:sp>
         <p:nvSpPr>
-          <p:cNvPr id="2067172308" name="Body Level One…"/>
+          <p:cNvPr id="1287819346" name="Body Level One…"/>
           <p:cNvSpPr txBox="1"/>
           <p:nvPr>
             <p:ph type="body" idx="1"/>
@@ -2092,7 +2092,7 @@
       </p:sp>
       <p:sp>
         <p:nvSpPr>
-          <p:cNvPr id="1006908168" name="Slide Number"/>
+          <p:cNvPr id="582554994" name="Slide Number"/>
           <p:cNvSpPr txBox="1"/>
           <p:nvPr>
             <p:ph type="sldNum" sz="quarter" idx="2"/>
@@ -2145,7 +2145,7 @@
       </p:grpSpPr>
       <p:sp>
         <p:nvSpPr>
-          <p:cNvPr id="317796159" name="Close-up of a red-eyed tree frog perched on a leaf"/>
+          <p:cNvPr id="1796979307" name="Close-up of a red-eyed tree frog perched on a leaf"/>
           <p:cNvSpPr/>
           <p:nvPr>
             <p:ph type="pic" sz="half" idx="21"/>
@@ -2175,7 +2175,7 @@
       </p:sp>
       <p:sp>
         <p:nvSpPr>
-          <p:cNvPr id="1593834194" name="Title Text"/>
+          <p:cNvPr id="415465102" name="Title Text"/>
           <p:cNvSpPr txBox="1"/>
           <p:nvPr>
             <p:ph type="title"/>
@@ -2203,7 +2203,7 @@
       </p:sp>
       <p:sp>
         <p:nvSpPr>
-          <p:cNvPr id="507921764" name="Body Level One…"/>
+          <p:cNvPr id="1462774100" name="Body Level One…"/>
           <p:cNvSpPr txBox="1"/>
           <p:nvPr>
             <p:ph type="body" sz="half" idx="1"/>
@@ -2316,7 +2316,7 @@
       </p:sp>
       <p:sp>
         <p:nvSpPr>
-          <p:cNvPr id="834635244" name="Slide Number"/>
+          <p:cNvPr id="1132880165" name="Slide Number"/>
           <p:cNvSpPr txBox="1"/>
           <p:nvPr>
             <p:ph type="sldNum" sz="quarter" idx="2"/>
@@ -2369,7 +2369,7 @@
       </p:grpSpPr>
       <p:sp>
         <p:nvSpPr>
-          <p:cNvPr id="164188852" name="Title Text"/>
+          <p:cNvPr id="854300286" name="Title Text"/>
           <p:cNvSpPr txBox="1"/>
           <p:nvPr>
             <p:ph type="title"/>
@@ -2397,7 +2397,7 @@
       </p:sp>
       <p:sp>
         <p:nvSpPr>
-          <p:cNvPr id="1517639646" name="Body Level One…"/>
+          <p:cNvPr id="2038968297" name="Body Level One…"/>
           <p:cNvSpPr txBox="1"/>
           <p:nvPr>
             <p:ph type="body" sz="half" idx="1"/>
@@ -2510,7 +2510,7 @@
       </p:sp>
       <p:sp>
         <p:nvSpPr>
-          <p:cNvPr id="776665343" name="Slide Number"/>
+          <p:cNvPr id="1002878642" name="Slide Number"/>
           <p:cNvSpPr txBox="1"/>
           <p:nvPr>
             <p:ph type="sldNum" sz="quarter" idx="2"/>
@@ -2563,7 +2563,7 @@
       </p:grpSpPr>
       <p:sp>
         <p:nvSpPr>
-          <p:cNvPr id="1147088599" name="Title Text"/>
+          <p:cNvPr id="1773530400" name="Title Text"/>
           <p:cNvSpPr txBox="1"/>
           <p:nvPr>
             <p:ph type="title"/>
@@ -2591,7 +2591,7 @@
       </p:sp>
       <p:sp>
         <p:nvSpPr>
-          <p:cNvPr id="1980641827" name="Body Level One…"/>
+          <p:cNvPr id="1689915861" name="Body Level One…"/>
           <p:cNvSpPr txBox="1"/>
           <p:nvPr>
             <p:ph type="body" sz="half" idx="1"/>
@@ -2704,7 +2704,7 @@
       </p:sp>
       <p:sp>
         <p:nvSpPr>
-          <p:cNvPr id="403513412" name="Slide Number"/>
+          <p:cNvPr id="171073485" name="Slide Number"/>
           <p:cNvSpPr txBox="1"/>
           <p:nvPr>
             <p:ph type="sldNum" sz="quarter" idx="2"/>
@@ -2764,7 +2764,7 @@
       </p:grpSpPr>
       <p:sp>
         <p:nvSpPr>
-          <p:cNvPr id="1978627024" name="Title Text"/>
+          <p:cNvPr id="398229804" name="Title Text"/>
           <p:cNvSpPr txBox="1"/>
           <p:nvPr>
             <p:ph type="title"/>
@@ -2801,7 +2801,7 @@
       </p:sp>
       <p:sp>
         <p:nvSpPr>
-          <p:cNvPr id="1387130379" name="Body Level One…"/>
+          <p:cNvPr id="1433514605" name="Body Level One…"/>
           <p:cNvSpPr txBox="1"/>
           <p:nvPr>
             <p:ph type="body" idx="1"/>
@@ -2878,7 +2878,7 @@
       </p:sp>
       <p:sp>
         <p:nvSpPr>
-          <p:cNvPr id="1409529237" name="Slide Number"/>
+          <p:cNvPr id="1567774541" name="Slide Number"/>
           <p:cNvSpPr txBox="1"/>
           <p:nvPr>
             <p:ph type="sldNum" sz="quarter" idx="2"/>
@@ -3612,7 +3612,7 @@
       </p:grpSpPr>
       <p:sp>
         <p:nvSpPr>
-          <p:cNvPr id="317537720" name="My Presentation"/>
+          <p:cNvPr id="787825161" name="My Presentation"/>
           <p:cNvSpPr txBox="1"/>
           <p:nvPr>
             <p:ph type="ctrTitle"/>
@@ -3640,7 +3640,7 @@
       </p:sp>
       <p:sp>
         <p:nvSpPr>
-          <p:cNvPr id="2134756337" name="Muhammad Zeeshan"/>
+          <p:cNvPr id="1159898914" name="Muhammad Zeeshan"/>
           <p:cNvSpPr txBox="1"/>
           <p:nvPr>
             <p:ph type="subTitle" sz="quarter" idx="1"/>
@@ -3660,7 +3660,7 @@
             </a:pPr>
             <a:r>
               <a:rPr/>
-              <a:t>Muhammad Zeeshan</a:t>
+              <a:t>Graham Steffaniak</a:t>
             </a:r>
             <a:endParaRPr/>
           </a:p>
@@ -3680,289 +3680,6 @@
     </mc:Fallback>
   </mc:AlternateContent>
 </p:sld>
-</file>
-
-<file path=ppt/theme/theme0.xml><?xml version="1.0" encoding="utf-8"?>
-<a:theme xmlns:a="http://schemas.openxmlformats.org/drawingml/2006/main" name="Office Theme">
-  <a:themeElements>
-    <a:clrScheme name="">
-      <a:dk1>
-        <a:srgbClr val="000000"/>
-      </a:dk1>
-      <a:lt1>
-        <a:srgbClr val="FFFFFF"/>
-      </a:lt1>
-      <a:dk2>
-        <a:srgbClr val="000000"/>
-      </a:dk2>
-      <a:lt2>
-        <a:srgbClr val="808080"/>
-      </a:lt2>
-      <a:accent1>
-        <a:srgbClr val="BBE0E3"/>
-      </a:accent1>
-      <a:accent2>
-        <a:srgbClr val="333399"/>
-      </a:accent2>
-      <a:accent3>
-        <a:srgbClr val="FFFFFF"/>
-      </a:accent3>
-      <a:accent4>
-        <a:srgbClr val="000000"/>
-      </a:accent4>
-      <a:accent5>
-        <a:srgbClr val="DAEDEF"/>
-      </a:accent5>
-      <a:accent6>
-        <a:srgbClr val="2D2D8A"/>
-      </a:accent6>
-      <a:hlink>
-        <a:srgbClr val="009999"/>
-      </a:hlink>
-      <a:folHlink>
-        <a:srgbClr val="99CC00"/>
-      </a:folHlink>
-    </a:clrScheme>
-    <a:fontScheme name="Office">
-      <a:majorFont>
-        <a:latin typeface="Calibri"/>
-        <a:ea typeface=""/>
-        <a:cs typeface=""/>
-        <a:font script="Jpan" typeface="ＭＳ Ｐゴシック"/>
-        <a:font script="Hang" typeface="맑은 고딕"/>
-        <a:font script="Hans" typeface="宋体"/>
-        <a:font script="Hant" typeface="新細明體"/>
-        <a:font script="Arab" typeface="Times New Roman"/>
-        <a:font script="Hebr" typeface="Times New Roman"/>
-        <a:font script="Thai" typeface="Angsana New"/>
-        <a:font script="Ethi" typeface="Nyala"/>
-        <a:font script="Beng" typeface="Vrinda"/>
-        <a:font script="Gujr" typeface="Shruti"/>
-        <a:font script="Khmr" typeface="MoolBoran"/>
-        <a:font script="Knda" typeface="Tunga"/>
-        <a:font script="Guru" typeface="Raavi"/>
-        <a:font script="Cans" typeface="Euphemia"/>
-        <a:font script="Cher" typeface="Plantagenet Cherokee"/>
-        <a:font script="Yiii" typeface="Microsoft Yi Baiti"/>
-        <a:font script="Tibt" typeface="Microsoft Himalaya"/>
-        <a:font script="Thaa" typeface="MV Boli"/>
-        <a:font script="Deva" typeface="Mangal"/>
-        <a:font script="Telu" typeface="Gautami"/>
-        <a:font script="Taml" typeface="Latha"/>
-        <a:font script="Syrc" typeface="Estrangelo Edessa"/>
-        <a:font script="Orya" typeface="Kalinga"/>
-        <a:font script="Mlym" typeface="Kartika"/>
-        <a:font script="Laoo" typeface="DokChampa"/>
-        <a:font script="Sinh" typeface="Iskoola Pota"/>
-        <a:font script="Mong" typeface="Mongolian Baiti"/>
-        <a:font script="Viet" typeface="Times New Roman"/>
-        <a:font script="Uigh" typeface="Microsoft Uighur"/>
-      </a:majorFont>
-      <a:minorFont>
-        <a:latin typeface="Calibri"/>
-        <a:ea typeface=""/>
-        <a:cs typeface=""/>
-        <a:font script="Jpan" typeface="ＭＳ Ｐゴシック"/>
-        <a:font script="Hang" typeface="맑은 고딕"/>
-        <a:font script="Hans" typeface="宋体"/>
-        <a:font script="Hant" typeface="新細明體"/>
-        <a:font script="Arab" typeface="Arial"/>
-        <a:font script="Hebr" typeface="Arial"/>
-        <a:font script="Thai" typeface="Cordia New"/>
-        <a:font script="Ethi" typeface="Nyala"/>
-        <a:font script="Beng" typeface="Vrinda"/>
-        <a:font script="Gujr" typeface="Shruti"/>
-        <a:font script="Khmr" typeface="DaunPenh"/>
-        <a:font script="Knda" typeface="Tunga"/>
-        <a:font script="Guru" typeface="Raavi"/>
-        <a:font script="Cans" typeface="Euphemia"/>
-        <a:font script="Cher" typeface="Plantagenet Cherokee"/>
-        <a:font script="Yiii" typeface="Microsoft Yi Baiti"/>
-        <a:font script="Tibt" typeface="Microsoft Himalaya"/>
-        <a:font script="Thaa" typeface="MV Boli"/>
-        <a:font script="Deva" typeface="Mangal"/>
-        <a:font script="Telu" typeface="Gautami"/>
-        <a:font script="Taml" typeface="Latha"/>
-        <a:font script="Syrc" typeface="Estrangelo Edessa"/>
-        <a:font script="Orya" typeface="Kalinga"/>
-        <a:font script="Mlym" typeface="Kartika"/>
-        <a:font script="Laoo" typeface="DokChampa"/>
-        <a:font script="Sinh" typeface="Iskoola Pota"/>
-        <a:font script="Mong" typeface="Mongolian Baiti"/>
-        <a:font script="Viet" typeface="Arial"/>
-        <a:font script="Uigh" typeface="Microsoft Uighur"/>
-      </a:minorFont>
-    </a:fontScheme>
-    <a:fmtScheme name="Office">
-      <a:fillStyleLst>
-        <a:solidFill>
-          <a:schemeClr val="phClr"/>
-        </a:solidFill>
-        <a:gradFill rotWithShape="1">
-          <a:gsLst>
-            <a:gs pos="0">
-              <a:schemeClr val="phClr">
-                <a:tint val="50000"/>
-                <a:satMod val="300000"/>
-              </a:schemeClr>
-            </a:gs>
-            <a:gs pos="35000">
-              <a:schemeClr val="phClr">
-                <a:tint val="37000"/>
-                <a:satMod val="300000"/>
-              </a:schemeClr>
-            </a:gs>
-            <a:gs pos="100000">
-              <a:schemeClr val="phClr">
-                <a:tint val="15000"/>
-                <a:satMod val="350000"/>
-              </a:schemeClr>
-            </a:gs>
-          </a:gsLst>
-          <a:lin ang="16200000" scaled="1"/>
-        </a:gradFill>
-        <a:gradFill rotWithShape="1">
-          <a:gsLst>
-            <a:gs pos="0">
-              <a:schemeClr val="phClr">
-                <a:shade val="51000"/>
-                <a:satMod val="130000"/>
-              </a:schemeClr>
-            </a:gs>
-            <a:gs pos="80000">
-              <a:schemeClr val="phClr">
-                <a:shade val="93000"/>
-                <a:satMod val="130000"/>
-              </a:schemeClr>
-            </a:gs>
-            <a:gs pos="100000">
-              <a:schemeClr val="phClr">
-                <a:shade val="94000"/>
-                <a:satMod val="135000"/>
-              </a:schemeClr>
-            </a:gs>
-          </a:gsLst>
-          <a:lin ang="16200000" scaled="0"/>
-        </a:gradFill>
-      </a:fillStyleLst>
-      <a:lnStyleLst>
-        <a:ln w="9525" cap="flat" cmpd="sng" algn="ctr">
-          <a:solidFill>
-            <a:schemeClr val="phClr">
-              <a:shade val="95000"/>
-              <a:satMod val="105000"/>
-            </a:schemeClr>
-          </a:solidFill>
-          <a:prstDash val="solid"/>
-        </a:ln>
-        <a:ln w="25400" cap="flat" cmpd="sng" algn="ctr">
-          <a:solidFill>
-            <a:schemeClr val="phClr"/>
-          </a:solidFill>
-          <a:prstDash val="solid"/>
-        </a:ln>
-        <a:ln w="38100" cap="flat" cmpd="sng" algn="ctr">
-          <a:solidFill>
-            <a:schemeClr val="phClr"/>
-          </a:solidFill>
-          <a:prstDash val="solid"/>
-        </a:ln>
-      </a:lnStyleLst>
-      <a:effectStyleLst>
-        <a:effectStyle>
-          <a:effectLst>
-            <a:outerShdw blurRad="40000" dist="20000" dir="5400000" rotWithShape="0">
-              <a:srgbClr val="000000">
-                <a:alpha val="38000"/>
-              </a:srgbClr>
-            </a:outerShdw>
-          </a:effectLst>
-        </a:effectStyle>
-        <a:effectStyle>
-          <a:effectLst>
-            <a:outerShdw blurRad="40000" dist="23000" dir="5400000" rotWithShape="0">
-              <a:srgbClr val="000000">
-                <a:alpha val="35000"/>
-              </a:srgbClr>
-            </a:outerShdw>
-          </a:effectLst>
-        </a:effectStyle>
-        <a:effectStyle>
-          <a:effectLst>
-            <a:outerShdw blurRad="40000" dist="23000" dir="5400000" rotWithShape="0">
-              <a:srgbClr val="000000">
-                <a:alpha val="35000"/>
-              </a:srgbClr>
-            </a:outerShdw>
-          </a:effectLst>
-          <a:scene3d>
-            <a:camera prst="orthographicFront">
-              <a:rot lat="0" lon="0" rev="0"/>
-            </a:camera>
-            <a:lightRig rig="threePt" dir="t">
-              <a:rot lat="0" lon="0" rev="1200000"/>
-            </a:lightRig>
-          </a:scene3d>
-          <a:sp3d>
-            <a:bevelT w="63500" h="25400"/>
-          </a:sp3d>
-        </a:effectStyle>
-      </a:effectStyleLst>
-      <a:bgFillStyleLst>
-        <a:solidFill>
-          <a:schemeClr val="phClr"/>
-        </a:solidFill>
-        <a:gradFill rotWithShape="1">
-          <a:gsLst>
-            <a:gs pos="0">
-              <a:schemeClr val="phClr">
-                <a:tint val="40000"/>
-                <a:satMod val="350000"/>
-              </a:schemeClr>
-            </a:gs>
-            <a:gs pos="40000">
-              <a:schemeClr val="phClr">
-                <a:tint val="45000"/>
-                <a:shade val="99000"/>
-                <a:satMod val="350000"/>
-              </a:schemeClr>
-            </a:gs>
-            <a:gs pos="100000">
-              <a:schemeClr val="phClr">
-                <a:shade val="20000"/>
-                <a:satMod val="255000"/>
-              </a:schemeClr>
-            </a:gs>
-          </a:gsLst>
-          <a:path path="circle">
-            <a:fillToRect l="50000" t="-80000" r="50000" b="180000"/>
-          </a:path>
-        </a:gradFill>
-        <a:gradFill rotWithShape="1">
-          <a:gsLst>
-            <a:gs pos="0">
-              <a:schemeClr val="phClr">
-                <a:tint val="80000"/>
-                <a:satMod val="300000"/>
-              </a:schemeClr>
-            </a:gs>
-            <a:gs pos="100000">
-              <a:schemeClr val="phClr">
-                <a:shade val="30000"/>
-                <a:satMod val="200000"/>
-              </a:schemeClr>
-            </a:gs>
-          </a:gsLst>
-          <a:path path="circle">
-            <a:fillToRect l="50000" t="50000" r="50000" b="50000"/>
-          </a:path>
-        </a:gradFill>
-      </a:bgFillStyleLst>
-    </a:fmtScheme>
-  </a:themeElements>
-  <a:objectDefaults/>
-  <a:extraClrSchemeLst/>
-</a:theme>
 </file>
 
 <file path=ppt/theme/theme1.xml><?xml version="1.0" encoding="utf-8"?>

</xml_diff>